<commit_message>
System Design vi: sd-10-026 userspace va phan con lai, OIDC, bo ghi chu Chromium khong chay
Co-Authored-By: Claude Sonnet 5.5 <noreply@anthropic.com>
Claude-Session: https://claude.ai/code/session_01JJCRKgpbfdpiPMwgBVozBY
</commit_message>
<xml_diff>
--- a/system-design-101/vi/lessons/sd-10-026/slides/sd-10-026.pptx
+++ b/system-design-101/vi/lessons/sd-10-026/slides/sd-10-026.pptx
@@ -4066,26 +4066,15 @@
               <a:t> initrd,</a:t>
             </a:r>
             <a:r>
-              <a:rPr lang="en-US" sz="2400" dirty="0" spc="0" kern="0">
-                <a:solidFill>
-                  <a:srgbClr val="14161C"/>
-                </a:solidFill>
-                <a:latin typeface="Be Vietnam Pro" pitchFamily="34" charset="0"/>
-                <a:ea typeface="Be Vietnam Pro" pitchFamily="34" charset="-122"/>
-                <a:cs typeface="Be Vietnam Pro" pitchFamily="34" charset="-120"/>
-              </a:rPr>
-              <a:t> dịch</a:t>
-            </a:r>
-            <a:r>
-              <a:rPr lang="en-US" sz="2400" dirty="0" spc="2" kern="0">
-                <a:solidFill>
-                  <a:srgbClr val="14161C"/>
-                </a:solidFill>
-                <a:latin typeface="Be Vietnam Pro" pitchFamily="34" charset="0"/>
-                <a:ea typeface="Be Vietnam Pro" pitchFamily="34" charset="-122"/>
-                <a:cs typeface="Be Vietnam Pro" pitchFamily="34" charset="-120"/>
-              </a:rPr>
-              <a:t> vụ</a:t>
+              <a:rPr lang="en-US" sz="2400" dirty="0" spc="-4" kern="0">
+                <a:solidFill>
+                  <a:srgbClr val="14161C"/>
+                </a:solidFill>
+                <a:latin typeface="Be Vietnam Pro" pitchFamily="34" charset="0"/>
+                <a:ea typeface="Be Vietnam Pro" pitchFamily="34" charset="-122"/>
+                <a:cs typeface="Be Vietnam Pro" pitchFamily="34" charset="-120"/>
+              </a:rPr>
+              <a:t> userspace</a:t>
             </a:r>
             <a:endParaRPr lang="en-US" sz="2400" dirty="0"/>
           </a:p>
@@ -5529,7 +5518,7 @@
               <a:t> và</a:t>
             </a:r>
             <a:r>
-              <a:rPr lang="en-US" sz="2700" dirty="0" spc="-1" kern="0">
+              <a:rPr lang="en-US" sz="2700" dirty="0" spc="-2" kern="0">
                 <a:solidFill>
                   <a:srgbClr val="F3EEE3"/>
                 </a:solidFill>
@@ -5537,10 +5526,10 @@
                 <a:ea typeface="Be Vietnam Pro" pitchFamily="34" charset="-122"/>
                 <a:cs typeface="Be Vietnam Pro" pitchFamily="34" charset="-120"/>
               </a:rPr>
-              <a:t> dịch</a:t>
-            </a:r>
-            <a:r>
-              <a:rPr lang="en-US" sz="2700" dirty="0" spc="-2" kern="0">
+              <a:t> không gian</a:t>
+            </a:r>
+            <a:r>
+              <a:rPr lang="en-US" sz="2700" dirty="0" spc="6" kern="0">
                 <a:solidFill>
                   <a:srgbClr val="F3EEE3"/>
                 </a:solidFill>
@@ -5548,7 +5537,18 @@
                 <a:ea typeface="Be Vietnam Pro" pitchFamily="34" charset="-122"/>
                 <a:cs typeface="Be Vietnam Pro" pitchFamily="34" charset="-120"/>
               </a:rPr>
-              <a:t> vụ.</a:t>
+              <a:t> người</a:t>
+            </a:r>
+            <a:r>
+              <a:rPr lang="en-US" sz="2700" dirty="0" spc="-3" kern="0">
+                <a:solidFill>
+                  <a:srgbClr val="F3EEE3"/>
+                </a:solidFill>
+                <a:latin typeface="Be Vietnam Pro" pitchFamily="34" charset="0"/>
+                <a:ea typeface="Be Vietnam Pro" pitchFamily="34" charset="-122"/>
+                <a:cs typeface="Be Vietnam Pro" pitchFamily="34" charset="-120"/>
+              </a:rPr>
+              <a:t> dùng.</a:t>
             </a:r>
             <a:endParaRPr lang="en-US" sz="2700" dirty="0"/>
           </a:p>

</xml_diff>

<commit_message>
System Design vi: sd-10-026 chuoi la manh moi, khong bao dam; deck va PPTX
Co-Authored-By: Claude Sonnet 5.5 <noreply@anthropic.com>
Claude-Session: https://claude.ai/code/session_01JJCRKgpbfdpiPMwgBVozBY
</commit_message>
<xml_diff>
--- a/system-design-101/vi/lessons/sd-10-026/slides/sd-10-026.pptx
+++ b/system-design-101/vi/lessons/sd-10-026/slides/sd-10-026.pptx
@@ -15977,6 +15977,17 @@
               </a:rPr>
               <a:t>Chưa</a:t>
             </a:r>
+            <a:r>
+              <a:rPr lang="en-US" sz="3300" dirty="0" spc="3" kern="0">
+                <a:solidFill>
+                  <a:srgbClr val="0F766E"/>
+                </a:solidFill>
+                <a:latin typeface="Bricolage Grotesque ExtraBold" pitchFamily="34" charset="0"/>
+                <a:ea typeface="Bricolage Grotesque ExtraBold" pitchFamily="34" charset="-122"/>
+                <a:cs typeface="Bricolage Grotesque ExtraBold" pitchFamily="34" charset="-120"/>
+              </a:rPr>
+              <a:t> chắc</a:t>
+            </a:r>
             <a:endParaRPr lang="en-US" sz="3300" dirty="0"/>
           </a:p>
         </p:txBody>
@@ -16115,29 +16126,51 @@
                 <a:ea typeface="Be Vietnam Pro" pitchFamily="34" charset="-122"/>
                 <a:cs typeface="Be Vietnam Pro" pitchFamily="34" charset="-120"/>
               </a:rPr>
-              <a:t> chuỗi</a:t>
-            </a:r>
-            <a:r>
-              <a:rPr lang="en-US" sz="2400" dirty="0" spc="-12" kern="0">
-                <a:solidFill>
-                  <a:srgbClr val="14161C"/>
-                </a:solidFill>
-                <a:latin typeface="Be Vietnam Pro" pitchFamily="34" charset="0"/>
-                <a:ea typeface="Be Vietnam Pro" pitchFamily="34" charset="-122"/>
-                <a:cs typeface="Be Vietnam Pro" pitchFamily="34" charset="-120"/>
-              </a:rPr>
-              <a:t> tới</a:t>
-            </a:r>
-            <a:r>
-              <a:rPr lang="en-US" sz="2400" dirty="0" spc="19" kern="0">
-                <a:solidFill>
-                  <a:srgbClr val="14161C"/>
-                </a:solidFill>
-                <a:latin typeface="Be Vietnam Pro" pitchFamily="34" charset="0"/>
-                <a:ea typeface="Be Vietnam Pro" pitchFamily="34" charset="-122"/>
-                <a:cs typeface="Be Vietnam Pro" pitchFamily="34" charset="-120"/>
-              </a:rPr>
-              <a:t> đích</a:t>
+              <a:t> chuỗi hiển</a:t>
+            </a:r>
+            <a:r>
+              <a:rPr lang="en-US" sz="2400" dirty="0" spc="1" kern="0">
+                <a:solidFill>
+                  <a:srgbClr val="14161C"/>
+                </a:solidFill>
+                <a:latin typeface="Be Vietnam Pro" pitchFamily="34" charset="0"/>
+                <a:ea typeface="Be Vietnam Pro" pitchFamily="34" charset="-122"/>
+                <a:cs typeface="Be Vietnam Pro" pitchFamily="34" charset="-120"/>
+              </a:rPr>
+              <a:t> thị;</a:t>
+            </a:r>
+            <a:r>
+              <a:rPr lang="en-US" sz="2400" dirty="0" spc="18" kern="0">
+                <a:solidFill>
+                  <a:srgbClr val="14161C"/>
+                </a:solidFill>
+                <a:latin typeface="Be Vietnam Pro" pitchFamily="34" charset="0"/>
+                <a:ea typeface="Be Vietnam Pro" pitchFamily="34" charset="-122"/>
+                <a:cs typeface="Be Vietnam Pro" pitchFamily="34" charset="-120"/>
+              </a:rPr>
+              <a:t> đo</a:t>
+            </a:r>
+            <a:r>
+              <a:rPr lang="en-US" sz="2400" dirty="0" spc="1" kern="0">
+                <a:solidFill>
+                  <a:srgbClr val="14161C"/>
+                </a:solidFill>
+                <a:latin typeface="Be Vietnam Pro" pitchFamily="34" charset="0"/>
+                <a:ea typeface="Be Vietnam Pro" pitchFamily="34" charset="-122"/>
+                <a:cs typeface="Be Vietnam Pro" pitchFamily="34" charset="-120"/>
+              </a:rPr>
+              <a:t> lại mới</a:t>
+            </a:r>
+            <a:r>
+              <a:rPr lang="en-US" sz="2400" dirty="0" spc="-4" kern="0">
+                <a:solidFill>
+                  <a:srgbClr val="14161C"/>
+                </a:solidFill>
+                <a:latin typeface="Be Vietnam Pro" pitchFamily="34" charset="0"/>
+                <a:ea typeface="Be Vietnam Pro" pitchFamily="34" charset="-122"/>
+                <a:cs typeface="Be Vietnam Pro" pitchFamily="34" charset="-120"/>
+              </a:rPr>
+              <a:t> biết</a:t>
             </a:r>
             <a:endParaRPr lang="en-US" sz="2400" dirty="0"/>
           </a:p>
@@ -18672,7 +18705,7 @@
               <a:buNone/>
             </a:pPr>
             <a:r>
-              <a:rPr lang="en-US" sz="2700" dirty="0" spc="-43" kern="0">
+              <a:rPr lang="en-US" sz="2700" dirty="0" spc="1" kern="0">
                 <a:solidFill>
                   <a:srgbClr val="F3EEE3"/>
                 </a:solidFill>
@@ -18680,10 +18713,10 @@
                 <a:ea typeface="Be Vietnam Pro" pitchFamily="34" charset="-122"/>
                 <a:cs typeface="Be Vietnam Pro" pitchFamily="34" charset="-120"/>
               </a:rPr>
-              <a:t>Rút</a:t>
-            </a:r>
-            <a:r>
-              <a:rPr lang="en-US" sz="2700" dirty="0" spc="-13" kern="0">
+              <a:t>Chuỗi</a:t>
+            </a:r>
+            <a:r>
+              <a:rPr lang="en-US" sz="2700" dirty="0" spc="-1" kern="0">
                 <a:solidFill>
                   <a:srgbClr val="F3EEE3"/>
                 </a:solidFill>
@@ -18691,10 +18724,10 @@
                 <a:ea typeface="Be Vietnam Pro" pitchFamily="34" charset="-122"/>
                 <a:cs typeface="Be Vietnam Pro" pitchFamily="34" charset="-120"/>
               </a:rPr>
-              <a:t> ngắn</a:t>
-            </a:r>
-            <a:r>
-              <a:rPr lang="en-US" sz="2700" dirty="0" spc="11" kern="0">
+              <a:t> là</a:t>
+            </a:r>
+            <a:r>
+              <a:rPr lang="en-US" sz="2700" dirty="0" spc="-2" kern="0">
                 <a:solidFill>
                   <a:srgbClr val="F3EEE3"/>
                 </a:solidFill>
@@ -18702,7 +18735,18 @@
                 <a:ea typeface="Be Vietnam Pro" pitchFamily="34" charset="-122"/>
                 <a:cs typeface="Be Vietnam Pro" pitchFamily="34" charset="-120"/>
               </a:rPr>
-              <a:t> đơn</a:t>
+              <a:t> manh</a:t>
+            </a:r>
+            <a:r>
+              <a:rPr lang="en-US" sz="2700" dirty="0" spc="-1" kern="0">
+                <a:solidFill>
+                  <a:srgbClr val="F3EEE3"/>
+                </a:solidFill>
+                <a:latin typeface="Be Vietnam Pro" pitchFamily="34" charset="0"/>
+                <a:ea typeface="Be Vietnam Pro" pitchFamily="34" charset="-122"/>
+                <a:cs typeface="Be Vietnam Pro" pitchFamily="34" charset="-120"/>
+              </a:rPr>
+              <a:t> mối,</a:t>
             </a:r>
             <a:r>
               <a:rPr lang="en-US" sz="2700" dirty="0" spc="-2" kern="0">
@@ -18713,10 +18757,10 @@
                 <a:ea typeface="Be Vietnam Pro" pitchFamily="34" charset="-122"/>
                 <a:cs typeface="Be Vietnam Pro" pitchFamily="34" charset="-120"/>
               </a:rPr>
-              <a:t> vị</a:t>
-            </a:r>
-            <a:r>
-              <a:rPr lang="en-US" sz="2700" dirty="0" spc="-24" kern="0">
+              <a:t> không</a:t>
+            </a:r>
+            <a:r>
+              <a:rPr lang="en-US" sz="2700" dirty="0" spc="-6" kern="0">
                 <a:solidFill>
                   <a:srgbClr val="F3EEE3"/>
                 </a:solidFill>
@@ -18724,10 +18768,10 @@
                 <a:ea typeface="Be Vietnam Pro" pitchFamily="34" charset="-122"/>
                 <a:cs typeface="Be Vietnam Pro" pitchFamily="34" charset="-120"/>
               </a:rPr>
-              <a:t> trên</a:t>
-            </a:r>
-            <a:r>
-              <a:rPr lang="en-US" sz="2700" dirty="0" spc="1" kern="0">
+              <a:t> bảo</a:t>
+            </a:r>
+            <a:r>
+              <a:rPr lang="en-US" sz="2700" dirty="0" spc="10" kern="0">
                 <a:solidFill>
                   <a:srgbClr val="F3EEE3"/>
                 </a:solidFill>
@@ -18735,7 +18779,7 @@
                 <a:ea typeface="Be Vietnam Pro" pitchFamily="34" charset="-122"/>
                 <a:cs typeface="Be Vietnam Pro" pitchFamily="34" charset="-120"/>
               </a:rPr>
-              <a:t> chuỗi</a:t>
+              <a:t> đảm:</a:t>
             </a:r>
             <a:endParaRPr lang="en-US" sz="2700" dirty="0"/>
           </a:p>
@@ -18747,6 +18791,28 @@
               <a:buNone/>
             </a:pPr>
             <a:r>
+              <a:rPr lang="en-US" sz="2700" dirty="0" spc="10" kern="0">
+                <a:solidFill>
+                  <a:srgbClr val="F3EEE3"/>
+                </a:solidFill>
+                <a:latin typeface="Be Vietnam Pro" pitchFamily="34" charset="0"/>
+                <a:ea typeface="Be Vietnam Pro" pitchFamily="34" charset="-122"/>
+                <a:cs typeface="Be Vietnam Pro" pitchFamily="34" charset="-120"/>
+              </a:rPr>
+              <a:t>sửa</a:t>
+            </a:r>
+            <a:r>
+              <a:rPr lang="en-US" sz="2700" dirty="0" spc="-20" kern="0">
+                <a:solidFill>
+                  <a:srgbClr val="F3EEE3"/>
+                </a:solidFill>
+                <a:latin typeface="Be Vietnam Pro" pitchFamily="34" charset="0"/>
+                <a:ea typeface="Be Vietnam Pro" pitchFamily="34" charset="-122"/>
+                <a:cs typeface="Be Vietnam Pro" pitchFamily="34" charset="-120"/>
+              </a:rPr>
+              <a:t> xong</a:t>
+            </a:r>
+            <a:r>
               <a:rPr lang="en-US" sz="2700" dirty="0" spc="-1" kern="0">
                 <a:solidFill>
                   <a:srgbClr val="F3EEE3"/>
@@ -18755,10 +18821,10 @@
                 <a:ea typeface="Be Vietnam Pro" pitchFamily="34" charset="-122"/>
                 <a:cs typeface="Be Vietnam Pro" pitchFamily="34" charset="-120"/>
               </a:rPr>
-              <a:t>mới</a:t>
-            </a:r>
-            <a:r>
-              <a:rPr lang="en-US" sz="2700" dirty="0" spc="9" kern="0">
+              <a:t> phải</a:t>
+            </a:r>
+            <a:r>
+              <a:rPr lang="en-US" sz="2700" dirty="0" spc="16" kern="0">
                 <a:solidFill>
                   <a:srgbClr val="F3EEE3"/>
                 </a:solidFill>
@@ -18766,10 +18832,10 @@
                 <a:ea typeface="Be Vietnam Pro" pitchFamily="34" charset="-122"/>
                 <a:cs typeface="Be Vietnam Pro" pitchFamily="34" charset="-120"/>
               </a:rPr>
-              <a:t> đưa</a:t>
-            </a:r>
-            <a:r>
-              <a:rPr lang="en-US" sz="2700" dirty="0" spc="21" kern="0">
+              <a:t> đo</a:t>
+            </a:r>
+            <a:r>
+              <a:rPr lang="en-US" sz="2700" dirty="0" spc="-1" kern="0">
                 <a:solidFill>
                   <a:srgbClr val="F3EEE3"/>
                 </a:solidFill>
@@ -18777,40 +18843,7 @@
                 <a:ea typeface="Be Vietnam Pro" pitchFamily="34" charset="-122"/>
                 <a:cs typeface="Be Vietnam Pro" pitchFamily="34" charset="-120"/>
               </a:rPr>
-              <a:t> đích</a:t>
-            </a:r>
-            <a:r>
-              <a:rPr lang="en-US" sz="2700" dirty="0" spc="-14" kern="0">
-                <a:solidFill>
-                  <a:srgbClr val="F3EEE3"/>
-                </a:solidFill>
-                <a:latin typeface="Be Vietnam Pro" pitchFamily="34" charset="0"/>
-                <a:ea typeface="Be Vietnam Pro" pitchFamily="34" charset="-122"/>
-                <a:cs typeface="Be Vietnam Pro" pitchFamily="34" charset="-120"/>
-              </a:rPr>
-              <a:t> tới</a:t>
-            </a:r>
-            <a:r>
-              <a:rPr lang="en-US" sz="2700" dirty="0" spc="-9" kern="0">
-                <a:solidFill>
-                  <a:srgbClr val="F3EEE3"/>
-                </a:solidFill>
-                <a:latin typeface="Be Vietnam Pro" pitchFamily="34" charset="0"/>
-                <a:ea typeface="Be Vietnam Pro" pitchFamily="34" charset="-122"/>
-                <a:cs typeface="Be Vietnam Pro" pitchFamily="34" charset="-120"/>
-              </a:rPr>
-              <a:t> sớm</a:t>
-            </a:r>
-            <a:r>
-              <a:rPr lang="en-US" sz="2700" dirty="0" spc="-3" kern="0">
-                <a:solidFill>
-                  <a:srgbClr val="F3EEE3"/>
-                </a:solidFill>
-                <a:latin typeface="Be Vietnam Pro" pitchFamily="34" charset="0"/>
-                <a:ea typeface="Be Vietnam Pro" pitchFamily="34" charset="-122"/>
-                <a:cs typeface="Be Vietnam Pro" pitchFamily="34" charset="-120"/>
-              </a:rPr>
-              <a:t> hơn.</a:t>
+              <a:t> lại.</a:t>
             </a:r>
             <a:endParaRPr lang="en-US" sz="2700" dirty="0"/>
           </a:p>

</xml_diff>